<commit_message>
slide de metodos y practicas editada
</commit_message>
<xml_diff>
--- a/public/archivos/corporativo/decks/Entelgy_Executive_Deck.pptx
+++ b/public/archivos/corporativo/decks/Entelgy_Executive_Deck.pptx
@@ -6555,64 +6555,22 @@
       </p:sp>
       <p:sp>
         <p:nvSpPr>
-          <p:cNvPr id="32" name="Text 25"/>
-          <p:cNvSpPr/>
-          <p:nvPr/>
-        </p:nvSpPr>
-        <p:spPr>
-          <a:xfrm>
-            <a:off x="1247775" y="7010995"/>
-            <a:ext cx="344835" cy="342900"/>
-          </a:xfrm>
-          <a:prstGeom prst="rect">
-            <a:avLst/>
-          </a:prstGeom>
-          <a:noFill/>
-          <a:ln/>
-        </p:spPr>
-        <p:txBody>
-          <a:bodyPr wrap="square" lIns="25400" tIns="25400" rIns="25400" bIns="25400" rtlCol="0" anchor="t">
-            <a:normAutofit lnSpcReduction="10000"/>
-          </a:bodyPr>
-          <a:lstStyle/>
-          <a:p>
-            <a:pPr marL="0" indent="0" algn="l">
-              <a:lnSpc>
-                <a:spcPct val="84211"/>
-              </a:lnSpc>
-              <a:buNone/>
-            </a:pPr>
-            <a:r>
-              <a:rPr lang="en-US" sz="2400" b="1" kern="0" spc="-48" dirty="0">
-                <a:solidFill>
-                  <a:srgbClr val="5E3D9B"/>
-                </a:solidFill>
-                <a:latin typeface="Barlow" pitchFamily="34" charset="0"/>
-                <a:ea typeface="Barlow" pitchFamily="34" charset="-122"/>
-                <a:cs typeface="Barlow" pitchFamily="34" charset="-120"/>
-              </a:rPr>
-              <a:t>01</a:t>
-            </a:r>
-            <a:endParaRPr lang="en-US" sz="2400" dirty="0"/>
-          </a:p>
-        </p:txBody>
-      </p:sp>
-      <p:sp>
-        <p:nvSpPr>
-          <p:cNvPr id="33" name="Shape 26"/>
-          <p:cNvSpPr/>
-          <p:nvPr/>
-        </p:nvSpPr>
-        <p:spPr>
-          <a:xfrm>
-            <a:off x="3632746" y="6982420"/>
-            <a:ext cx="361950" cy="361950"/>
-          </a:xfrm>
-          <a:prstGeom prst="ellipse">
-            <a:avLst/>
+          <p:cNvPr id="9001" name="Chip"/>
+          <p:cNvSpPr/>
+          <p:nvPr/>
+        </p:nvSpPr>
+        <p:spPr>
+          <a:xfrm>
+            <a:off x="1247775" y="6963370"/>
+            <a:ext cx="342900" cy="342900"/>
+          </a:xfrm>
+          <a:prstGeom prst="roundRect">
+            <a:avLst>
+              <a:gd name="adj" fmla="val 26000"/>
+            </a:avLst>
           </a:prstGeom>
           <a:solidFill>
-            <a:srgbClr val="EEF1F4"/>
+            <a:srgbClr val="EDE3F7"/>
           </a:solidFill>
           <a:ln/>
         </p:spPr>
@@ -6626,9 +6584,7 @@
       </p:sp>
       <p:pic>
         <p:nvPicPr>
-          <p:cNvPr id="34" name="Image 5" descr="preencoded.png">
-            <a:hlinkClick r:id="rId10" action="ppaction://hlinksldjump"/>
-          </p:cNvPr>
+          <p:cNvPr id="35" name="Image 6" descr="preencoded.png"/>
           <p:cNvPicPr>
             <a:picLocks noChangeAspect="1"/>
           </p:cNvPicPr>
@@ -6638,7 +6594,7 @@
           <a:blip>
             <a:extLst>
               <a:ext uri="{96DAC541-7B7A-43D3-8B79-37D633B846F1}">
-                <asvg:svgBlip xmlns:asvg="http://schemas.microsoft.com/office/drawing/2016/SVG/main" r:embed="rId11"/>
+                <asvg:svgBlip xmlns:asvg="http://schemas.microsoft.com/office/drawing/2016/SVG/main" r:embed="rId25"/>
               </a:ext>
             </a:extLst>
           </a:blip>
@@ -6648,39 +6604,8 @@
         </p:blipFill>
         <p:spPr>
           <a:xfrm>
-            <a:off x="3718471" y="7068145"/>
-            <a:ext cx="190500" cy="190500"/>
-          </a:xfrm>
-          <a:prstGeom prst="rect">
-            <a:avLst/>
-          </a:prstGeom>
-        </p:spPr>
-      </p:pic>
-      <p:pic>
-        <p:nvPicPr>
-          <p:cNvPr id="35" name="Image 6" descr="preencoded.png"/>
-          <p:cNvPicPr>
-            <a:picLocks noChangeAspect="1"/>
-          </p:cNvPicPr>
-          <p:nvPr/>
-        </p:nvPicPr>
-        <p:blipFill>
-          <a:blip>
-            <a:alphaModFix amt="8000"/>
-            <a:extLst>
-              <a:ext uri="{96DAC541-7B7A-43D3-8B79-37D633B846F1}">
-                <asvg:svgBlip xmlns:asvg="http://schemas.microsoft.com/office/drawing/2016/SVG/main" r:embed="rId12"/>
-              </a:ext>
-            </a:extLst>
-          </a:blip>
-          <a:stretch>
-            <a:fillRect/>
-          </a:stretch>
-        </p:blipFill>
-        <p:spPr>
-          <a:xfrm>
-            <a:off x="2923953" y="8175531"/>
-            <a:ext cx="1108843" cy="1108843"/>
+            <a:off x="1314450" y="7030045"/>
+            <a:ext cx="209550" cy="209550"/>
           </a:xfrm>
           <a:prstGeom prst="rect">
             <a:avLst/>
@@ -6889,64 +6814,22 @@
       </p:sp>
       <p:sp>
         <p:nvSpPr>
-          <p:cNvPr id="41" name="Text 32"/>
-          <p:cNvSpPr/>
-          <p:nvPr/>
-        </p:nvSpPr>
-        <p:spPr>
-          <a:xfrm>
-            <a:off x="4509046" y="7010995"/>
-            <a:ext cx="411212" cy="342900"/>
-          </a:xfrm>
-          <a:prstGeom prst="rect">
-            <a:avLst/>
-          </a:prstGeom>
-          <a:noFill/>
-          <a:ln/>
-        </p:spPr>
-        <p:txBody>
-          <a:bodyPr wrap="square" lIns="25400" tIns="25400" rIns="25400" bIns="25400" rtlCol="0" anchor="t">
-            <a:normAutofit lnSpcReduction="10000"/>
-          </a:bodyPr>
-          <a:lstStyle/>
-          <a:p>
-            <a:pPr marL="0" indent="0" algn="l">
-              <a:lnSpc>
-                <a:spcPct val="84211"/>
-              </a:lnSpc>
-              <a:buNone/>
-            </a:pPr>
-            <a:r>
-              <a:rPr lang="en-US" sz="2400" b="1" kern="0" spc="-48" dirty="0">
-                <a:solidFill>
-                  <a:srgbClr val="4D7CA8"/>
-                </a:solidFill>
-                <a:latin typeface="Barlow" pitchFamily="34" charset="0"/>
-                <a:ea typeface="Barlow" pitchFamily="34" charset="-122"/>
-                <a:cs typeface="Barlow" pitchFamily="34" charset="-120"/>
-              </a:rPr>
-              <a:t>02</a:t>
-            </a:r>
-            <a:endParaRPr lang="en-US" sz="2400" dirty="0"/>
-          </a:p>
-        </p:txBody>
-      </p:sp>
-      <p:sp>
-        <p:nvSpPr>
-          <p:cNvPr id="42" name="Shape 33"/>
-          <p:cNvSpPr/>
-          <p:nvPr/>
-        </p:nvSpPr>
-        <p:spPr>
-          <a:xfrm>
-            <a:off x="6894165" y="6982420"/>
-            <a:ext cx="361950" cy="361950"/>
-          </a:xfrm>
-          <a:prstGeom prst="ellipse">
-            <a:avLst/>
+          <p:cNvPr id="9002" name="Chip"/>
+          <p:cNvSpPr/>
+          <p:nvPr/>
+        </p:nvSpPr>
+        <p:spPr>
+          <a:xfrm>
+            <a:off x="4509046" y="6963370"/>
+            <a:ext cx="342900" cy="342900"/>
+          </a:xfrm>
+          <a:prstGeom prst="roundRect">
+            <a:avLst>
+              <a:gd name="adj" fmla="val 26000"/>
+            </a:avLst>
           </a:prstGeom>
           <a:solidFill>
-            <a:srgbClr val="EEF1F4"/>
+            <a:srgbClr val="DCEAF6"/>
           </a:solidFill>
           <a:ln/>
         </p:spPr>
@@ -6960,9 +6843,7 @@
       </p:sp>
       <p:pic>
         <p:nvPicPr>
-          <p:cNvPr id="43" name="Image 7" descr="preencoded.png">
-            <a:hlinkClick r:id="rId13" action="ppaction://hlinksldjump"/>
-          </p:cNvPr>
+          <p:cNvPr id="44" name="Image 8" descr="preencoded.png"/>
           <p:cNvPicPr>
             <a:picLocks noChangeAspect="1"/>
           </p:cNvPicPr>
@@ -6972,7 +6853,7 @@
           <a:blip>
             <a:extLst>
               <a:ext uri="{96DAC541-7B7A-43D3-8B79-37D633B846F1}">
-                <asvg:svgBlip xmlns:asvg="http://schemas.microsoft.com/office/drawing/2016/SVG/main" r:embed="rId14"/>
+                <asvg:svgBlip xmlns:asvg="http://schemas.microsoft.com/office/drawing/2016/SVG/main" r:embed="rId26"/>
               </a:ext>
             </a:extLst>
           </a:blip>
@@ -6982,39 +6863,8 @@
         </p:blipFill>
         <p:spPr>
           <a:xfrm>
-            <a:off x="6979890" y="7068145"/>
-            <a:ext cx="190500" cy="190500"/>
-          </a:xfrm>
-          <a:prstGeom prst="rect">
-            <a:avLst/>
-          </a:prstGeom>
-        </p:spPr>
-      </p:pic>
-      <p:pic>
-        <p:nvPicPr>
-          <p:cNvPr id="44" name="Image 8" descr="preencoded.png"/>
-          <p:cNvPicPr>
-            <a:picLocks noChangeAspect="1"/>
-          </p:cNvPicPr>
-          <p:nvPr/>
-        </p:nvPicPr>
-        <p:blipFill>
-          <a:blip>
-            <a:alphaModFix amt="8000"/>
-            <a:extLst>
-              <a:ext uri="{96DAC541-7B7A-43D3-8B79-37D633B846F1}">
-                <asvg:svgBlip xmlns:asvg="http://schemas.microsoft.com/office/drawing/2016/SVG/main" r:embed="rId15"/>
-              </a:ext>
-            </a:extLst>
-          </a:blip>
-          <a:stretch>
-            <a:fillRect/>
-          </a:stretch>
-        </p:blipFill>
-        <p:spPr>
-          <a:xfrm>
-            <a:off x="6185372" y="8175531"/>
-            <a:ext cx="1108843" cy="1108843"/>
+            <a:off x="4575721" y="7030045"/>
+            <a:ext cx="209550" cy="209550"/>
           </a:xfrm>
           <a:prstGeom prst="rect">
             <a:avLst/>
@@ -7223,66 +7073,22 @@
       </p:sp>
       <p:sp>
         <p:nvSpPr>
-          <p:cNvPr id="50" name="Text 39"/>
-          <p:cNvSpPr/>
-          <p:nvPr/>
-        </p:nvSpPr>
-        <p:spPr>
-          <a:xfrm>
-            <a:off x="7770465" y="7010995"/>
-            <a:ext cx="405110" cy="342900"/>
-          </a:xfrm>
-          <a:prstGeom prst="rect">
-            <a:avLst/>
-          </a:prstGeom>
-          <a:noFill/>
-          <a:ln/>
-        </p:spPr>
-        <p:txBody>
-          <a:bodyPr wrap="square" lIns="25400" tIns="25400" rIns="25400" bIns="25400" rtlCol="0" anchor="t">
-            <a:normAutofit lnSpcReduction="10000"/>
-          </a:bodyPr>
-          <a:lstStyle/>
-          <a:p>
-            <a:pPr marL="0" indent="0" algn="l">
-              <a:lnSpc>
-                <a:spcPct val="84211"/>
-              </a:lnSpc>
-              <a:buNone/>
-            </a:pPr>
-            <a:r>
-              <a:rPr lang="en-US" sz="2400" b="1" kern="0" spc="-48" dirty="0">
-                <a:solidFill>
-                  <a:srgbClr val="3A8E63"/>
-                </a:solidFill>
-                <a:latin typeface="Barlow" pitchFamily="34" charset="0"/>
-                <a:ea typeface="Barlow" pitchFamily="34" charset="-122"/>
-                <a:cs typeface="Barlow" pitchFamily="34" charset="-120"/>
-              </a:rPr>
-              <a:t>03</a:t>
-            </a:r>
-            <a:endParaRPr lang="en-US" sz="2400" dirty="0"/>
-          </a:p>
-        </p:txBody>
-      </p:sp>
-      <p:sp>
-        <p:nvSpPr>
-          <p:cNvPr id="51" name="Shape 40">
-            <a:hlinkClick r:id="rId16" action="ppaction://hlinksldjump"/>
-          </p:cNvPr>
-          <p:cNvSpPr/>
-          <p:nvPr/>
-        </p:nvSpPr>
-        <p:spPr>
-          <a:xfrm>
-            <a:off x="10155436" y="6982420"/>
-            <a:ext cx="361950" cy="361950"/>
-          </a:xfrm>
-          <a:prstGeom prst="ellipse">
-            <a:avLst/>
+          <p:cNvPr id="9003" name="Chip"/>
+          <p:cNvSpPr/>
+          <p:nvPr/>
+        </p:nvSpPr>
+        <p:spPr>
+          <a:xfrm>
+            <a:off x="7770465" y="6963370"/>
+            <a:ext cx="342900" cy="342900"/>
+          </a:xfrm>
+          <a:prstGeom prst="roundRect">
+            <a:avLst>
+              <a:gd name="adj" fmla="val 26000"/>
+            </a:avLst>
           </a:prstGeom>
           <a:solidFill>
-            <a:srgbClr val="EEF1F4"/>
+            <a:srgbClr val="D6F1E2"/>
           </a:solidFill>
           <a:ln/>
         </p:spPr>
@@ -7296,7 +7102,7 @@
       </p:sp>
       <p:pic>
         <p:nvPicPr>
-          <p:cNvPr id="52" name="Image 9" descr="preencoded.png"/>
+          <p:cNvPr id="53" name="Image 10" descr="preencoded.png"/>
           <p:cNvPicPr>
             <a:picLocks noChangeAspect="1"/>
           </p:cNvPicPr>
@@ -7306,7 +7112,7 @@
           <a:blip>
             <a:extLst>
               <a:ext uri="{96DAC541-7B7A-43D3-8B79-37D633B846F1}">
-                <asvg:svgBlip xmlns:asvg="http://schemas.microsoft.com/office/drawing/2016/SVG/main" r:embed="rId17"/>
+                <asvg:svgBlip xmlns:asvg="http://schemas.microsoft.com/office/drawing/2016/SVG/main" r:embed="rId27"/>
               </a:ext>
             </a:extLst>
           </a:blip>
@@ -7316,39 +7122,8 @@
         </p:blipFill>
         <p:spPr>
           <a:xfrm>
-            <a:off x="10241161" y="7068145"/>
-            <a:ext cx="190500" cy="190500"/>
-          </a:xfrm>
-          <a:prstGeom prst="rect">
-            <a:avLst/>
-          </a:prstGeom>
-        </p:spPr>
-      </p:pic>
-      <p:pic>
-        <p:nvPicPr>
-          <p:cNvPr id="53" name="Image 10" descr="preencoded.png"/>
-          <p:cNvPicPr>
-            <a:picLocks noChangeAspect="1"/>
-          </p:cNvPicPr>
-          <p:nvPr/>
-        </p:nvPicPr>
-        <p:blipFill>
-          <a:blip>
-            <a:alphaModFix amt="8000"/>
-            <a:extLst>
-              <a:ext uri="{96DAC541-7B7A-43D3-8B79-37D633B846F1}">
-                <asvg:svgBlip xmlns:asvg="http://schemas.microsoft.com/office/drawing/2016/SVG/main" r:embed="rId18"/>
-              </a:ext>
-            </a:extLst>
-          </a:blip>
-          <a:stretch>
-            <a:fillRect/>
-          </a:stretch>
-        </p:blipFill>
-        <p:spPr>
-          <a:xfrm>
-            <a:off x="9446643" y="8175531"/>
-            <a:ext cx="1108843" cy="1108843"/>
+            <a:off x="7837140" y="7030045"/>
+            <a:ext cx="209550" cy="209550"/>
           </a:xfrm>
           <a:prstGeom prst="rect">
             <a:avLst/>
@@ -7557,64 +7332,22 @@
       </p:sp>
       <p:sp>
         <p:nvSpPr>
-          <p:cNvPr id="59" name="Text 46"/>
-          <p:cNvSpPr/>
-          <p:nvPr/>
-        </p:nvSpPr>
-        <p:spPr>
-          <a:xfrm>
-            <a:off x="11031736" y="7010995"/>
-            <a:ext cx="428327" cy="342900"/>
-          </a:xfrm>
-          <a:prstGeom prst="rect">
-            <a:avLst/>
-          </a:prstGeom>
-          <a:noFill/>
-          <a:ln/>
-        </p:spPr>
-        <p:txBody>
-          <a:bodyPr wrap="square" lIns="25400" tIns="25400" rIns="25400" bIns="25400" rtlCol="0" anchor="t">
-            <a:normAutofit lnSpcReduction="10000"/>
-          </a:bodyPr>
-          <a:lstStyle/>
-          <a:p>
-            <a:pPr marL="0" indent="0" algn="l">
-              <a:lnSpc>
-                <a:spcPct val="84211"/>
-              </a:lnSpc>
-              <a:buNone/>
-            </a:pPr>
-            <a:r>
-              <a:rPr lang="en-US" sz="2400" b="1" kern="0" spc="-48" dirty="0">
-                <a:solidFill>
-                  <a:srgbClr val="9E335E"/>
-                </a:solidFill>
-                <a:latin typeface="Barlow" pitchFamily="34" charset="0"/>
-                <a:ea typeface="Barlow" pitchFamily="34" charset="-122"/>
-                <a:cs typeface="Barlow" pitchFamily="34" charset="-120"/>
-              </a:rPr>
-              <a:t>04</a:t>
-            </a:r>
-            <a:endParaRPr lang="en-US" sz="2400" dirty="0"/>
-          </a:p>
-        </p:txBody>
-      </p:sp>
-      <p:sp>
-        <p:nvSpPr>
-          <p:cNvPr id="60" name="Shape 47"/>
-          <p:cNvSpPr/>
-          <p:nvPr/>
-        </p:nvSpPr>
-        <p:spPr>
-          <a:xfrm>
-            <a:off x="13416855" y="6982420"/>
-            <a:ext cx="361950" cy="361950"/>
-          </a:xfrm>
-          <a:prstGeom prst="ellipse">
-            <a:avLst/>
+          <p:cNvPr id="9004" name="Chip"/>
+          <p:cNvSpPr/>
+          <p:nvPr/>
+        </p:nvSpPr>
+        <p:spPr>
+          <a:xfrm>
+            <a:off x="11031736" y="6963370"/>
+            <a:ext cx="342900" cy="342900"/>
+          </a:xfrm>
+          <a:prstGeom prst="roundRect">
+            <a:avLst>
+              <a:gd name="adj" fmla="val 26000"/>
+            </a:avLst>
           </a:prstGeom>
           <a:solidFill>
-            <a:srgbClr val="EEF1F4"/>
+            <a:srgbClr val="F7DCE7"/>
           </a:solidFill>
           <a:ln/>
         </p:spPr>
@@ -7628,9 +7361,7 @@
       </p:sp>
       <p:pic>
         <p:nvPicPr>
-          <p:cNvPr id="61" name="Image 11" descr="preencoded.png">
-            <a:hlinkClick r:id="rId19" action="ppaction://hlinksldjump"/>
-          </p:cNvPr>
+          <p:cNvPr id="62" name="Image 12" descr="preencoded.png"/>
           <p:cNvPicPr>
             <a:picLocks noChangeAspect="1"/>
           </p:cNvPicPr>
@@ -7640,7 +7371,7 @@
           <a:blip>
             <a:extLst>
               <a:ext uri="{96DAC541-7B7A-43D3-8B79-37D633B846F1}">
-                <asvg:svgBlip xmlns:asvg="http://schemas.microsoft.com/office/drawing/2016/SVG/main" r:embed="rId20"/>
+                <asvg:svgBlip xmlns:asvg="http://schemas.microsoft.com/office/drawing/2016/SVG/main" r:embed="rId28"/>
               </a:ext>
             </a:extLst>
           </a:blip>
@@ -7650,39 +7381,8 @@
         </p:blipFill>
         <p:spPr>
           <a:xfrm>
-            <a:off x="13502580" y="7068145"/>
-            <a:ext cx="190500" cy="190500"/>
-          </a:xfrm>
-          <a:prstGeom prst="rect">
-            <a:avLst/>
-          </a:prstGeom>
-        </p:spPr>
-      </p:pic>
-      <p:pic>
-        <p:nvPicPr>
-          <p:cNvPr id="62" name="Image 12" descr="preencoded.png"/>
-          <p:cNvPicPr>
-            <a:picLocks noChangeAspect="1"/>
-          </p:cNvPicPr>
-          <p:nvPr/>
-        </p:nvPicPr>
-        <p:blipFill>
-          <a:blip>
-            <a:alphaModFix amt="8000"/>
-            <a:extLst>
-              <a:ext uri="{96DAC541-7B7A-43D3-8B79-37D633B846F1}">
-                <asvg:svgBlip xmlns:asvg="http://schemas.microsoft.com/office/drawing/2016/SVG/main" r:embed="rId21"/>
-              </a:ext>
-            </a:extLst>
-          </a:blip>
-          <a:stretch>
-            <a:fillRect/>
-          </a:stretch>
-        </p:blipFill>
-        <p:spPr>
-          <a:xfrm>
-            <a:off x="12708062" y="8175531"/>
-            <a:ext cx="1108843" cy="1108843"/>
+            <a:off x="11098411" y="7030045"/>
+            <a:ext cx="209550" cy="209550"/>
           </a:xfrm>
           <a:prstGeom prst="rect">
             <a:avLst/>
@@ -7891,64 +7591,22 @@
       </p:sp>
       <p:sp>
         <p:nvSpPr>
-          <p:cNvPr id="68" name="Text 53"/>
-          <p:cNvSpPr/>
-          <p:nvPr/>
-        </p:nvSpPr>
-        <p:spPr>
-          <a:xfrm>
-            <a:off x="14293155" y="7010995"/>
-            <a:ext cx="404813" cy="342900"/>
-          </a:xfrm>
-          <a:prstGeom prst="rect">
-            <a:avLst/>
-          </a:prstGeom>
-          <a:noFill/>
-          <a:ln/>
-        </p:spPr>
-        <p:txBody>
-          <a:bodyPr wrap="square" lIns="25400" tIns="25400" rIns="25400" bIns="25400" rtlCol="0" anchor="t">
-            <a:normAutofit lnSpcReduction="10000"/>
-          </a:bodyPr>
-          <a:lstStyle/>
-          <a:p>
-            <a:pPr marL="0" indent="0" algn="l">
-              <a:lnSpc>
-                <a:spcPct val="84211"/>
-              </a:lnSpc>
-              <a:buNone/>
-            </a:pPr>
-            <a:r>
-              <a:rPr lang="en-US" sz="2400" b="1" kern="0" spc="-48" dirty="0">
-                <a:solidFill>
-                  <a:srgbClr val="C73F00"/>
-                </a:solidFill>
-                <a:latin typeface="Barlow" pitchFamily="34" charset="0"/>
-                <a:ea typeface="Barlow" pitchFamily="34" charset="-122"/>
-                <a:cs typeface="Barlow" pitchFamily="34" charset="-120"/>
-              </a:rPr>
-              <a:t>05</a:t>
-            </a:r>
-            <a:endParaRPr lang="en-US" sz="2400" dirty="0"/>
-          </a:p>
-        </p:txBody>
-      </p:sp>
-      <p:sp>
-        <p:nvSpPr>
-          <p:cNvPr id="69" name="Shape 54"/>
-          <p:cNvSpPr/>
-          <p:nvPr/>
-        </p:nvSpPr>
-        <p:spPr>
-          <a:xfrm>
-            <a:off x="16678126" y="6982420"/>
-            <a:ext cx="361950" cy="361950"/>
-          </a:xfrm>
-          <a:prstGeom prst="ellipse">
-            <a:avLst/>
+          <p:cNvPr id="9005" name="Chip"/>
+          <p:cNvSpPr/>
+          <p:nvPr/>
+        </p:nvSpPr>
+        <p:spPr>
+          <a:xfrm>
+            <a:off x="14293155" y="6963370"/>
+            <a:ext cx="342900" cy="342900"/>
+          </a:xfrm>
+          <a:prstGeom prst="roundRect">
+            <a:avLst>
+              <a:gd name="adj" fmla="val 26000"/>
+            </a:avLst>
           </a:prstGeom>
           <a:solidFill>
-            <a:srgbClr val="EEF1F4"/>
+            <a:srgbClr val="FFE0CC"/>
           </a:solidFill>
           <a:ln/>
         </p:spPr>
@@ -7962,9 +7620,7 @@
       </p:sp>
       <p:pic>
         <p:nvPicPr>
-          <p:cNvPr id="70" name="Image 13" descr="preencoded.png">
-            <a:hlinkClick r:id="rId22" action="ppaction://hlinksldjump"/>
-          </p:cNvPr>
+          <p:cNvPr id="71" name="Image 14" descr="preencoded.png"/>
           <p:cNvPicPr>
             <a:picLocks noChangeAspect="1"/>
           </p:cNvPicPr>
@@ -7974,7 +7630,7 @@
           <a:blip>
             <a:extLst>
               <a:ext uri="{96DAC541-7B7A-43D3-8B79-37D633B846F1}">
-                <asvg:svgBlip xmlns:asvg="http://schemas.microsoft.com/office/drawing/2016/SVG/main" r:embed="rId23"/>
+                <asvg:svgBlip xmlns:asvg="http://schemas.microsoft.com/office/drawing/2016/SVG/main" r:embed="rId29"/>
               </a:ext>
             </a:extLst>
           </a:blip>
@@ -7984,39 +7640,8 @@
         </p:blipFill>
         <p:spPr>
           <a:xfrm>
-            <a:off x="16763851" y="7068145"/>
-            <a:ext cx="190500" cy="190500"/>
-          </a:xfrm>
-          <a:prstGeom prst="rect">
-            <a:avLst/>
-          </a:prstGeom>
-        </p:spPr>
-      </p:pic>
-      <p:pic>
-        <p:nvPicPr>
-          <p:cNvPr id="71" name="Image 14" descr="preencoded.png"/>
-          <p:cNvPicPr>
-            <a:picLocks noChangeAspect="1"/>
-          </p:cNvPicPr>
-          <p:nvPr/>
-        </p:nvPicPr>
-        <p:blipFill>
-          <a:blip>
-            <a:alphaModFix amt="8000"/>
-            <a:extLst>
-              <a:ext uri="{96DAC541-7B7A-43D3-8B79-37D633B846F1}">
-                <asvg:svgBlip xmlns:asvg="http://schemas.microsoft.com/office/drawing/2016/SVG/main" r:embed="rId24"/>
-              </a:ext>
-            </a:extLst>
-          </a:blip>
-          <a:stretch>
-            <a:fillRect/>
-          </a:stretch>
-        </p:blipFill>
-        <p:spPr>
-          <a:xfrm>
-            <a:off x="15969333" y="8175531"/>
-            <a:ext cx="1108843" cy="1108843"/>
+            <a:off x="14359830" y="7030045"/>
+            <a:ext cx="209550" cy="209550"/>
           </a:xfrm>
           <a:prstGeom prst="rect">
             <a:avLst/>

</xml_diff>